<commit_message>
Date: 10 Apr 2026
</commit_message>
<xml_diff>
--- a/Data Driven Framework.pptx
+++ b/Data Driven Framework.pptx
@@ -2107,21 +2107,21 @@
     </dgm:pt>
   </dgm:ptLst>
   <dgm:cxnLst>
+    <dgm:cxn modelId="{63A80EE8-96E2-4895-A0FD-D1BCA82D5E5B}" type="presOf" srcId="{4564C817-85A5-49C5-A042-0743418AB0B9}" destId="{2A835CC2-1B15-4BB9-845F-057520BE8D4C}" srcOrd="0" destOrd="0" presId="urn:microsoft.com/office/officeart/2005/8/layout/process2"/>
+    <dgm:cxn modelId="{5B273185-4733-457B-BC4A-70B265A7F4D3}" type="presOf" srcId="{0478B1E6-8F89-451F-9615-FFDD2527D84B}" destId="{0CAC7AB9-0753-45DD-9E85-9E83C4793BBC}" srcOrd="1" destOrd="0" presId="urn:microsoft.com/office/officeart/2005/8/layout/process2"/>
+    <dgm:cxn modelId="{EA8C4341-E990-4980-9C3A-08B4B2AB7342}" type="presOf" srcId="{849DF79E-D907-4332-A05A-C73B75CE47D7}" destId="{69EA0E30-B88D-4AE5-8A7D-43D0AA7A3A67}" srcOrd="0" destOrd="0" presId="urn:microsoft.com/office/officeart/2005/8/layout/process2"/>
     <dgm:cxn modelId="{B3702B81-06D7-4241-A722-8913070A943D}" type="presOf" srcId="{B040B286-3DB1-41CD-9F84-FE90A3D16003}" destId="{63BCD0C0-FCF7-4B8D-9DA9-0F884DC956B9}" srcOrd="1" destOrd="0" presId="urn:microsoft.com/office/officeart/2005/8/layout/process2"/>
     <dgm:cxn modelId="{AEA00177-7C99-4A11-B4B4-18A99D4DB226}" srcId="{4564C817-85A5-49C5-A042-0743418AB0B9}" destId="{BAE3384C-62B9-4A1C-95E8-A82114B3363E}" srcOrd="0" destOrd="0" parTransId="{C9745FE9-602C-4983-931C-89A9549F733D}" sibTransId="{0478B1E6-8F89-451F-9615-FFDD2527D84B}"/>
+    <dgm:cxn modelId="{CF49D998-F738-4CC4-86EC-3FBD8276CB03}" type="presOf" srcId="{BAE3384C-62B9-4A1C-95E8-A82114B3363E}" destId="{2CA69046-5A66-431B-9F09-12F48849F7C1}" srcOrd="0" destOrd="0" presId="urn:microsoft.com/office/officeart/2005/8/layout/process2"/>
+    <dgm:cxn modelId="{62F42B2B-48BA-40AC-959F-455772866D44}" type="presOf" srcId="{001D1743-1483-4843-A383-BB8DE04E3D95}" destId="{05499B92-0FFC-499C-82AD-80631E8B972E}" srcOrd="0" destOrd="0" presId="urn:microsoft.com/office/officeart/2005/8/layout/process2"/>
+    <dgm:cxn modelId="{ECCF9058-8A97-4CD7-8215-D5B9BA11EB3E}" srcId="{4564C817-85A5-49C5-A042-0743418AB0B9}" destId="{001D1743-1483-4843-A383-BB8DE04E3D95}" srcOrd="2" destOrd="0" parTransId="{A20D0C5D-66B2-490E-B071-49201187F74C}" sibTransId="{B040B286-3DB1-41CD-9F84-FE90A3D16003}"/>
+    <dgm:cxn modelId="{90A6619B-F712-4383-99F6-BAB4EAFEA52A}" type="presOf" srcId="{B040B286-3DB1-41CD-9F84-FE90A3D16003}" destId="{84744D81-1CBC-4F9D-BB6F-72D24B873ECD}" srcOrd="0" destOrd="0" presId="urn:microsoft.com/office/officeart/2005/8/layout/process2"/>
+    <dgm:cxn modelId="{F26F69B9-96A5-478C-BB9E-452E6A309B7A}" srcId="{4564C817-85A5-49C5-A042-0743418AB0B9}" destId="{849DF79E-D907-4332-A05A-C73B75CE47D7}" srcOrd="1" destOrd="0" parTransId="{E48635B3-74BE-43E5-9D2F-E643DD6EB769}" sibTransId="{AD57084A-E6AE-4DA2-A521-4D2815F56D16}"/>
     <dgm:cxn modelId="{A1AB331D-8094-43AE-8765-C2045E5CC865}" type="presOf" srcId="{18884ABC-D470-4158-BC8B-EB171208C89A}" destId="{3799E177-0C34-4EC1-B48E-39209B5D14B4}" srcOrd="0" destOrd="0" presId="urn:microsoft.com/office/officeart/2005/8/layout/process2"/>
-    <dgm:cxn modelId="{39CA3015-AF6D-4588-B2C8-F4571A462447}" type="presOf" srcId="{AD57084A-E6AE-4DA2-A521-4D2815F56D16}" destId="{1792F3C5-0C7C-47D8-9B57-EACBAC4C47D4}" srcOrd="0" destOrd="0" presId="urn:microsoft.com/office/officeart/2005/8/layout/process2"/>
-    <dgm:cxn modelId="{62F42B2B-48BA-40AC-959F-455772866D44}" type="presOf" srcId="{001D1743-1483-4843-A383-BB8DE04E3D95}" destId="{05499B92-0FFC-499C-82AD-80631E8B972E}" srcOrd="0" destOrd="0" presId="urn:microsoft.com/office/officeart/2005/8/layout/process2"/>
-    <dgm:cxn modelId="{5B273185-4733-457B-BC4A-70B265A7F4D3}" type="presOf" srcId="{0478B1E6-8F89-451F-9615-FFDD2527D84B}" destId="{0CAC7AB9-0753-45DD-9E85-9E83C4793BBC}" srcOrd="1" destOrd="0" presId="urn:microsoft.com/office/officeart/2005/8/layout/process2"/>
+    <dgm:cxn modelId="{75AEB5D1-349B-49DB-9DB8-F29082AA82C9}" srcId="{4564C817-85A5-49C5-A042-0743418AB0B9}" destId="{18884ABC-D470-4158-BC8B-EB171208C89A}" srcOrd="3" destOrd="0" parTransId="{D710A81F-C71D-420D-A6EB-67D06C6C1A43}" sibTransId="{1F3FBDA2-9F81-4715-85B0-79709ADC2BB4}"/>
     <dgm:cxn modelId="{FBC8D4C2-FD18-4258-88D5-819A8314ACD1}" type="presOf" srcId="{AD57084A-E6AE-4DA2-A521-4D2815F56D16}" destId="{90E5EC91-741F-498E-A79D-6241C6CA557A}" srcOrd="1" destOrd="0" presId="urn:microsoft.com/office/officeart/2005/8/layout/process2"/>
     <dgm:cxn modelId="{01F87BBD-1816-4574-B440-2F8A8BD6F555}" type="presOf" srcId="{0478B1E6-8F89-451F-9615-FFDD2527D84B}" destId="{EEA40E06-726F-4835-BEB6-9AF33E1D5BAE}" srcOrd="0" destOrd="0" presId="urn:microsoft.com/office/officeart/2005/8/layout/process2"/>
-    <dgm:cxn modelId="{ECCF9058-8A97-4CD7-8215-D5B9BA11EB3E}" srcId="{4564C817-85A5-49C5-A042-0743418AB0B9}" destId="{001D1743-1483-4843-A383-BB8DE04E3D95}" srcOrd="2" destOrd="0" parTransId="{A20D0C5D-66B2-490E-B071-49201187F74C}" sibTransId="{B040B286-3DB1-41CD-9F84-FE90A3D16003}"/>
-    <dgm:cxn modelId="{CF49D998-F738-4CC4-86EC-3FBD8276CB03}" type="presOf" srcId="{BAE3384C-62B9-4A1C-95E8-A82114B3363E}" destId="{2CA69046-5A66-431B-9F09-12F48849F7C1}" srcOrd="0" destOrd="0" presId="urn:microsoft.com/office/officeart/2005/8/layout/process2"/>
-    <dgm:cxn modelId="{F26F69B9-96A5-478C-BB9E-452E6A309B7A}" srcId="{4564C817-85A5-49C5-A042-0743418AB0B9}" destId="{849DF79E-D907-4332-A05A-C73B75CE47D7}" srcOrd="1" destOrd="0" parTransId="{E48635B3-74BE-43E5-9D2F-E643DD6EB769}" sibTransId="{AD57084A-E6AE-4DA2-A521-4D2815F56D16}"/>
-    <dgm:cxn modelId="{90A6619B-F712-4383-99F6-BAB4EAFEA52A}" type="presOf" srcId="{B040B286-3DB1-41CD-9F84-FE90A3D16003}" destId="{84744D81-1CBC-4F9D-BB6F-72D24B873ECD}" srcOrd="0" destOrd="0" presId="urn:microsoft.com/office/officeart/2005/8/layout/process2"/>
-    <dgm:cxn modelId="{75AEB5D1-349B-49DB-9DB8-F29082AA82C9}" srcId="{4564C817-85A5-49C5-A042-0743418AB0B9}" destId="{18884ABC-D470-4158-BC8B-EB171208C89A}" srcOrd="3" destOrd="0" parTransId="{D710A81F-C71D-420D-A6EB-67D06C6C1A43}" sibTransId="{1F3FBDA2-9F81-4715-85B0-79709ADC2BB4}"/>
-    <dgm:cxn modelId="{EA8C4341-E990-4980-9C3A-08B4B2AB7342}" type="presOf" srcId="{849DF79E-D907-4332-A05A-C73B75CE47D7}" destId="{69EA0E30-B88D-4AE5-8A7D-43D0AA7A3A67}" srcOrd="0" destOrd="0" presId="urn:microsoft.com/office/officeart/2005/8/layout/process2"/>
-    <dgm:cxn modelId="{63A80EE8-96E2-4895-A0FD-D1BCA82D5E5B}" type="presOf" srcId="{4564C817-85A5-49C5-A042-0743418AB0B9}" destId="{2A835CC2-1B15-4BB9-845F-057520BE8D4C}" srcOrd="0" destOrd="0" presId="urn:microsoft.com/office/officeart/2005/8/layout/process2"/>
+    <dgm:cxn modelId="{39CA3015-AF6D-4588-B2C8-F4571A462447}" type="presOf" srcId="{AD57084A-E6AE-4DA2-A521-4D2815F56D16}" destId="{1792F3C5-0C7C-47D8-9B57-EACBAC4C47D4}" srcOrd="0" destOrd="0" presId="urn:microsoft.com/office/officeart/2005/8/layout/process2"/>
     <dgm:cxn modelId="{AE9374F2-9D3B-4643-852E-A779B9F2D2CF}" type="presParOf" srcId="{2A835CC2-1B15-4BB9-845F-057520BE8D4C}" destId="{2CA69046-5A66-431B-9F09-12F48849F7C1}" srcOrd="0" destOrd="0" presId="urn:microsoft.com/office/officeart/2005/8/layout/process2"/>
     <dgm:cxn modelId="{9989364E-448F-4C11-B97E-2066E8A7929B}" type="presParOf" srcId="{2A835CC2-1B15-4BB9-845F-057520BE8D4C}" destId="{EEA40E06-726F-4835-BEB6-9AF33E1D5BAE}" srcOrd="1" destOrd="0" presId="urn:microsoft.com/office/officeart/2005/8/layout/process2"/>
     <dgm:cxn modelId="{CE46A530-6F82-483D-B300-98C981712151}" type="presParOf" srcId="{EEA40E06-726F-4835-BEB6-9AF33E1D5BAE}" destId="{0CAC7AB9-0753-45DD-9E85-9E83C4793BBC}" srcOrd="0" destOrd="0" presId="urn:microsoft.com/office/officeart/2005/8/layout/process2"/>
@@ -2274,11 +2274,11 @@
     </dgm:pt>
   </dgm:ptLst>
   <dgm:cxnLst>
+    <dgm:cxn modelId="{0775F312-B9A6-4A45-AA08-2F7CBC54AD81}" srcId="{1D8228EC-33D5-42FA-BE29-F4B53E38EC22}" destId="{C935D552-D55B-4C41-A618-BA84BAB6B465}" srcOrd="1" destOrd="0" parTransId="{F63AB669-10CE-461B-9EFA-13D5E8AC9BCF}" sibTransId="{0476A815-FACC-428A-A11F-9EAAB5EB856B}"/>
+    <dgm:cxn modelId="{4F4FF7DB-22FE-4E9B-896A-347AF41023D2}" type="presOf" srcId="{C935D552-D55B-4C41-A618-BA84BAB6B465}" destId="{6AD56BF5-6EAE-4D1D-8261-89FDA4D428B0}" srcOrd="0" destOrd="0" presId="urn:microsoft.com/office/officeart/2005/8/layout/chevron1"/>
     <dgm:cxn modelId="{1BA16464-18F8-4B42-8B40-22B65FCEE1FC}" type="presOf" srcId="{0E8F6B52-047F-48AE-845E-041B54DA4A33}" destId="{0E48C185-E3E7-4BAB-B6B1-9CC40DF6B6A9}" srcOrd="0" destOrd="0" presId="urn:microsoft.com/office/officeart/2005/8/layout/chevron1"/>
+    <dgm:cxn modelId="{FB031CAF-241E-4EBC-BADB-1BEEA339D734}" srcId="{1D8228EC-33D5-42FA-BE29-F4B53E38EC22}" destId="{0E8F6B52-047F-48AE-845E-041B54DA4A33}" srcOrd="0" destOrd="0" parTransId="{7A5396B7-0ECD-4B12-8AB9-AB12417C5C76}" sibTransId="{E67AACB2-4510-4FE9-A168-D537C49B2D57}"/>
     <dgm:cxn modelId="{B3F154AE-9B53-4C7E-8A6A-74F3EE18A910}" type="presOf" srcId="{1D8228EC-33D5-42FA-BE29-F4B53E38EC22}" destId="{9ABFA52E-8A27-40B4-B232-B78975C44960}" srcOrd="0" destOrd="0" presId="urn:microsoft.com/office/officeart/2005/8/layout/chevron1"/>
-    <dgm:cxn modelId="{4F4FF7DB-22FE-4E9B-896A-347AF41023D2}" type="presOf" srcId="{C935D552-D55B-4C41-A618-BA84BAB6B465}" destId="{6AD56BF5-6EAE-4D1D-8261-89FDA4D428B0}" srcOrd="0" destOrd="0" presId="urn:microsoft.com/office/officeart/2005/8/layout/chevron1"/>
-    <dgm:cxn modelId="{FB031CAF-241E-4EBC-BADB-1BEEA339D734}" srcId="{1D8228EC-33D5-42FA-BE29-F4B53E38EC22}" destId="{0E8F6B52-047F-48AE-845E-041B54DA4A33}" srcOrd="0" destOrd="0" parTransId="{7A5396B7-0ECD-4B12-8AB9-AB12417C5C76}" sibTransId="{E67AACB2-4510-4FE9-A168-D537C49B2D57}"/>
-    <dgm:cxn modelId="{0775F312-B9A6-4A45-AA08-2F7CBC54AD81}" srcId="{1D8228EC-33D5-42FA-BE29-F4B53E38EC22}" destId="{C935D552-D55B-4C41-A618-BA84BAB6B465}" srcOrd="1" destOrd="0" parTransId="{F63AB669-10CE-461B-9EFA-13D5E8AC9BCF}" sibTransId="{0476A815-FACC-428A-A11F-9EAAB5EB856B}"/>
     <dgm:cxn modelId="{AED3659C-F40A-44EE-AE30-884C81DD2854}" type="presParOf" srcId="{9ABFA52E-8A27-40B4-B232-B78975C44960}" destId="{0E48C185-E3E7-4BAB-B6B1-9CC40DF6B6A9}" srcOrd="0" destOrd="0" presId="urn:microsoft.com/office/officeart/2005/8/layout/chevron1"/>
     <dgm:cxn modelId="{BF29CC83-8CF0-4FFF-B1DC-7BF909E1A3D2}" type="presParOf" srcId="{9ABFA52E-8A27-40B4-B232-B78975C44960}" destId="{FC1B0200-2953-4766-B6B0-2BA15602FB77}" srcOrd="1" destOrd="0" presId="urn:microsoft.com/office/officeart/2005/8/layout/chevron1"/>
     <dgm:cxn modelId="{F81911D4-0FB2-440F-A3AD-12B7AAEAEEFE}" type="presParOf" srcId="{9ABFA52E-8A27-40B4-B232-B78975C44960}" destId="{6AD56BF5-6EAE-4D1D-8261-89FDA4D428B0}" srcOrd="2" destOrd="0" presId="urn:microsoft.com/office/officeart/2005/8/layout/chevron1"/>
@@ -6611,7 +6611,7 @@
             <a:fld id="{B61BEF0D-F0BB-DE4B-95CE-6DB70DBA9567}" type="datetimeFigureOut">
               <a:rPr lang="en-US" dirty="0"/>
               <a:pPr/>
-              <a:t>4/9/2026</a:t>
+              <a:t>4/10/2026</a:t>
             </a:fld>
             <a:endParaRPr lang="en-US" dirty="0"/>
           </a:p>
@@ -6859,7 +6859,7 @@
             <a:fld id="{B61BEF0D-F0BB-DE4B-95CE-6DB70DBA9567}" type="datetimeFigureOut">
               <a:rPr lang="en-US" dirty="0"/>
               <a:pPr/>
-              <a:t>4/9/2026</a:t>
+              <a:t>4/10/2026</a:t>
             </a:fld>
             <a:endParaRPr lang="en-US" dirty="0"/>
           </a:p>
@@ -7170,7 +7170,7 @@
             <a:fld id="{B61BEF0D-F0BB-DE4B-95CE-6DB70DBA9567}" type="datetimeFigureOut">
               <a:rPr lang="en-US" dirty="0"/>
               <a:pPr/>
-              <a:t>4/9/2026</a:t>
+              <a:t>4/10/2026</a:t>
             </a:fld>
             <a:endParaRPr lang="en-US" dirty="0"/>
           </a:p>
@@ -7508,7 +7508,7 @@
             <a:fld id="{B61BEF0D-F0BB-DE4B-95CE-6DB70DBA9567}" type="datetimeFigureOut">
               <a:rPr lang="en-US" dirty="0"/>
               <a:pPr/>
-              <a:t>4/9/2026</a:t>
+              <a:t>4/10/2026</a:t>
             </a:fld>
             <a:endParaRPr lang="en-US" dirty="0"/>
           </a:p>
@@ -7819,7 +7819,7 @@
             <a:fld id="{B61BEF0D-F0BB-DE4B-95CE-6DB70DBA9567}" type="datetimeFigureOut">
               <a:rPr lang="en-US" dirty="0"/>
               <a:pPr/>
-              <a:t>4/9/2026</a:t>
+              <a:t>4/10/2026</a:t>
             </a:fld>
             <a:endParaRPr lang="en-US" dirty="0"/>
           </a:p>
@@ -8209,7 +8209,7 @@
             <a:fld id="{B61BEF0D-F0BB-DE4B-95CE-6DB70DBA9567}" type="datetimeFigureOut">
               <a:rPr lang="en-US" dirty="0"/>
               <a:pPr/>
-              <a:t>4/9/2026</a:t>
+              <a:t>4/10/2026</a:t>
             </a:fld>
             <a:endParaRPr lang="en-US" dirty="0"/>
           </a:p>
@@ -8375,7 +8375,7 @@
           <a:p>
             <a:fld id="{55C6B4A9-1611-4792-9094-5F34BCA07E0B}" type="datetimeFigureOut">
               <a:rPr lang="en-US" dirty="0"/>
-              <a:t>4/9/2026</a:t>
+              <a:t>4/10/2026</a:t>
             </a:fld>
             <a:endParaRPr lang="en-US" dirty="0"/>
           </a:p>
@@ -8551,7 +8551,7 @@
             <a:fld id="{B61BEF0D-F0BB-DE4B-95CE-6DB70DBA9567}" type="datetimeFigureOut">
               <a:rPr lang="en-US" dirty="0"/>
               <a:pPr/>
-              <a:t>4/9/2026</a:t>
+              <a:t>4/10/2026</a:t>
             </a:fld>
             <a:endParaRPr lang="en-US" dirty="0"/>
           </a:p>
@@ -8724,7 +8724,7 @@
             <a:fld id="{B61BEF0D-F0BB-DE4B-95CE-6DB70DBA9567}" type="datetimeFigureOut">
               <a:rPr lang="en-US" dirty="0"/>
               <a:pPr/>
-              <a:t>4/9/2026</a:t>
+              <a:t>4/10/2026</a:t>
             </a:fld>
             <a:endParaRPr lang="en-US" dirty="0"/>
           </a:p>
@@ -8968,7 +8968,7 @@
             <a:fld id="{B61BEF0D-F0BB-DE4B-95CE-6DB70DBA9567}" type="datetimeFigureOut">
               <a:rPr lang="en-US" dirty="0"/>
               <a:pPr/>
-              <a:t>4/9/2026</a:t>
+              <a:t>4/10/2026</a:t>
             </a:fld>
             <a:endParaRPr lang="en-US" dirty="0"/>
           </a:p>
@@ -9196,7 +9196,7 @@
           <a:p>
             <a:fld id="{EB712588-04B1-427B-82EE-E8DB90309F08}" type="datetimeFigureOut">
               <a:rPr lang="en-US" dirty="0"/>
-              <a:t>4/9/2026</a:t>
+              <a:t>4/10/2026</a:t>
             </a:fld>
             <a:endParaRPr lang="en-US" dirty="0"/>
           </a:p>
@@ -9566,7 +9566,7 @@
             <a:fld id="{B61BEF0D-F0BB-DE4B-95CE-6DB70DBA9567}" type="datetimeFigureOut">
               <a:rPr lang="en-US" dirty="0"/>
               <a:pPr/>
-              <a:t>4/9/2026</a:t>
+              <a:t>4/10/2026</a:t>
             </a:fld>
             <a:endParaRPr lang="en-US" dirty="0"/>
           </a:p>
@@ -9686,7 +9686,7 @@
             <a:fld id="{B61BEF0D-F0BB-DE4B-95CE-6DB70DBA9567}" type="datetimeFigureOut">
               <a:rPr lang="en-US" dirty="0"/>
               <a:pPr/>
-              <a:t>4/9/2026</a:t>
+              <a:t>4/10/2026</a:t>
             </a:fld>
             <a:endParaRPr lang="en-US" dirty="0"/>
           </a:p>
@@ -9778,7 +9778,7 @@
             <a:fld id="{B61BEF0D-F0BB-DE4B-95CE-6DB70DBA9567}" type="datetimeFigureOut">
               <a:rPr lang="en-US" dirty="0"/>
               <a:pPr/>
-              <a:t>4/9/2026</a:t>
+              <a:t>4/10/2026</a:t>
             </a:fld>
             <a:endParaRPr lang="en-US" dirty="0"/>
           </a:p>
@@ -10029,7 +10029,7 @@
           <a:p>
             <a:fld id="{42A54C80-263E-416B-A8E0-580EDEADCBDC}" type="datetimeFigureOut">
               <a:rPr lang="en-US" dirty="0"/>
-              <a:t>4/9/2026</a:t>
+              <a:t>4/10/2026</a:t>
             </a:fld>
             <a:endParaRPr lang="en-US" dirty="0"/>
           </a:p>
@@ -10288,7 +10288,7 @@
             <a:fld id="{B61BEF0D-F0BB-DE4B-95CE-6DB70DBA9567}" type="datetimeFigureOut">
               <a:rPr lang="en-US" dirty="0"/>
               <a:pPr/>
-              <a:t>4/9/2026</a:t>
+              <a:t>4/10/2026</a:t>
             </a:fld>
             <a:endParaRPr lang="en-US" dirty="0"/>
           </a:p>
@@ -11028,7 +11028,7 @@
             <a:fld id="{B61BEF0D-F0BB-DE4B-95CE-6DB70DBA9567}" type="datetimeFigureOut">
               <a:rPr lang="en-US" dirty="0"/>
               <a:pPr/>
-              <a:t>4/9/2026</a:t>
+              <a:t>4/10/2026</a:t>
             </a:fld>
             <a:endParaRPr lang="en-US" dirty="0"/>
           </a:p>

</xml_diff>